<commit_message>
docs: point links and Argo CD repoURL to NeuralSynth/DevOps-Capstone-Project
</commit_message>
<xml_diff>
--- a/demo/LiftLog-presentation.pptx
+++ b/demo/LiftLog-presentation.pptx
@@ -117,36 +117,36 @@
   <p:extLst>
     <p:ext uri="{521415D9-36F7-43E2-AB2F-B90AF26B5E84}">
       <p14:sectionLst xmlns:p14="http://schemas.microsoft.com/office/powerpoint/2010/main">
-        <p14:section name="Introduction" id="{c91b794f-23fd-7d7a-579d-70eb0fb1a5d2}">
+        <p14:section name="Introduction" id="{54e9c5ca-da25-5dd4-57ea-74e56cd6f088}">
           <p14:sldIdLst>
             <p14:sldId id="256"/>
             <p14:sldId id="257"/>
           </p14:sldIdLst>
         </p14:section>
-        <p14:section name="Build" id="{c30b8f40-a5a1-2061-ce51-872d526fb1ac}">
+        <p14:section name="Build" id="{2cfafdad-f930-36a9-7582-69b306a55e7c}">
           <p14:sldIdLst>
             <p14:sldId id="258"/>
             <p14:sldId id="259"/>
           </p14:sldIdLst>
         </p14:section>
-        <p14:section name="Delivery" id="{a70effc1-441b-8975-a14d-851b1a122f71}">
+        <p14:section name="Delivery" id="{64a5e8c2-b1fa-6f98-d2c8-59c83c242d55}">
           <p14:sldIdLst>
             <p14:sldId id="260"/>
           </p14:sldIdLst>
         </p14:section>
-        <p14:section name="Platform" id="{57dd8f4c-2224-eaa1-a9a2-c0ab0e748858}">
+        <p14:section name="Platform" id="{09035e54-4583-47d2-8c18-8d843e29122e}">
           <p14:sldIdLst>
             <p14:sldId id="261"/>
             <p14:sldId id="262"/>
           </p14:sldIdLst>
         </p14:section>
-        <p14:section name="Operate" id="{b3a62cc1-cee0-667f-7455-112e6f993fcc}">
+        <p14:section name="Operate" id="{c04002d8-aaff-5b87-ecee-fbdbc61a7358}">
           <p14:sldIdLst>
             <p14:sldId id="263"/>
             <p14:sldId id="264"/>
           </p14:sldIdLst>
         </p14:section>
-        <p14:section name="Wrap-up" id="{cf204118-64ef-e484-783c-e78a26b0b618}">
+        <p14:section name="Wrap-up" id="{aafefcab-65ae-5c59-308d-dbe823cb64ca}">
           <p14:sldIdLst>
             <p14:sldId id="265"/>
             <p14:sldId id="266"/>
@@ -3905,7 +3905,7 @@
                   </a:extLst>
                 </a:hlinkClick>
               </a:rPr>
-              <a:t>NeuralSynth/devops-heros-s21-liftlog</a:t>
+              <a:t>NeuralSynth/DevOps-Capstone-Project</a:t>
             </a:r>
             <a:endParaRPr lang="en-US" sz="1200" dirty="0"/>
           </a:p>

</xml_diff>